<commit_message>
Résultats de l’exécution locale
</commit_message>
<xml_diff>
--- a/S4_soutenance.pptx
+++ b/S4_soutenance.pptx
@@ -117,21 +117,21 @@
   <p:extLst>
     <p:ext uri="{521415D9-36F7-43E2-AB2F-B90AF26B5E84}">
       <p14:sectionLst xmlns:p14="http://schemas.microsoft.com/office/powerpoint/2010/main">
-        <p14:section name="Problème" id="{c9a64ce6-86d6-20c2-dc76-4869476ac995}">
+        <p14:section name="Problème" id="{30cba286-efbc-6beb-a181-49774418f966}">
           <p14:sldIdLst>
             <p14:sldId id="256"/>
             <p14:sldId id="257"/>
             <p14:sldId id="258"/>
           </p14:sldIdLst>
         </p14:section>
-        <p14:section name="Méthode" id="{94ffa340-b14b-986a-beff-4c1daab7212c}">
+        <p14:section name="Méthode" id="{678bec25-e905-1c46-9a6a-df1a477190dc}">
           <p14:sldIdLst>
             <p14:sldId id="259"/>
             <p14:sldId id="260"/>
             <p14:sldId id="261"/>
           </p14:sldIdLst>
         </p14:section>
-        <p14:section name="Résultats" id="{ece0b53a-de00-d06f-657d-3868422e7b86}">
+        <p14:section name="Résultats" id="{3eb2ca53-b8b2-a129-4f0e-ddb9df88f2b1}">
           <p14:sldIdLst>
             <p14:sldId id="262"/>
             <p14:sldId id="263"/>
@@ -139,7 +139,7 @@
             <p14:sldId id="265"/>
           </p14:sldIdLst>
         </p14:section>
-        <p14:section name="Conclusion" id="{1e6f54e4-ff91-2318-1306-5c0548ed4854}">
+        <p14:section name="Conclusion" id="{ebab76a7-cee9-3b70-691a-7a86dbb6b288}">
           <p14:sldIdLst>
             <p14:sldId id="266"/>
           </p14:sldIdLst>
@@ -652,19 +652,19 @@
                 <c:formatCode>General</c:formatCode>
                 <c:ptCount val="5"/>
                 <c:pt idx="0">
-                  <c:v>0.859</c:v>
+                  <c:v>0.857</c:v>
                 </c:pt>
                 <c:pt idx="1">
-                  <c:v>0.859</c:v>
+                  <c:v>0.858</c:v>
                 </c:pt>
                 <c:pt idx="2">
                   <c:v>0.862</c:v>
                 </c:pt>
                 <c:pt idx="3">
-                  <c:v>0.882</c:v>
+                  <c:v>0.881</c:v>
                 </c:pt>
                 <c:pt idx="4">
-                  <c:v>0.884</c:v>
+                  <c:v>0.883</c:v>
                 </c:pt>
               </c:numCache>
             </c:numRef>
@@ -778,10 +778,10 @@
                   <c:v>0.811</c:v>
                 </c:pt>
                 <c:pt idx="2">
-                  <c:v>0.817</c:v>
+                  <c:v>0.818</c:v>
                 </c:pt>
                 <c:pt idx="3">
-                  <c:v>0.875</c:v>
+                  <c:v>0.874</c:v>
                 </c:pt>
                 <c:pt idx="4">
                   <c:v>0.885</c:v>
@@ -984,7 +984,7 @@
                 </a:solidFill>
                 <a:latin typeface="+mn-lt"/>
               </a:rPr>
-              <a:t>534 erreurs de H à 10 % (graine 0), par brique responsable</a:t>
+              <a:t>527 erreurs de H à 10 % (graine 0), par brique responsable</a:t>
             </a:r>
           </a:p>
         </c:rich>
@@ -1176,13 +1176,13 @@
               <c:numCache>
                 <c:ptCount val="3"/>
                 <c:pt idx="0">
-                  <c:v>291</c:v>
+                  <c:v>295</c:v>
                 </c:pt>
                 <c:pt idx="1">
-                  <c:v>228</c:v>
+                  <c:v>224</c:v>
                 </c:pt>
                 <c:pt idx="2">
-                  <c:v>15</c:v>
+                  <c:v>8</c:v>
                 </c:pt>
               </c:numCache>
             </c:numRef>
@@ -1344,10 +1344,10 @@
                 <c:formatCode>General</c:formatCode>
                 <c:ptCount val="2"/>
                 <c:pt idx="0">
-                  <c:v>42.8</c:v>
+                  <c:v>44.2</c:v>
                 </c:pt>
                 <c:pt idx="1">
-                  <c:v>19.6</c:v>
+                  <c:v>18.1</c:v>
                 </c:pt>
               </c:numCache>
             </c:numRef>
@@ -1421,10 +1421,10 @@
                 <c:formatCode>General</c:formatCode>
                 <c:ptCount val="2"/>
                 <c:pt idx="0">
-                  <c:v>22.5</c:v>
+                  <c:v>24.8</c:v>
                 </c:pt>
                 <c:pt idx="1">
-                  <c:v>28.1</c:v>
+                  <c:v>26.5</c:v>
                 </c:pt>
               </c:numCache>
             </c:numRef>
@@ -2069,7 +2069,7 @@
           <a:p>
             <a:r>
               <a:rPr lang="en-US" dirty="0"/>
-              <a:t>ALEXIS (1:15). Pour exploiter l'incertitude : d'abord la température, qui ramène l'ECE de 0,14 à 0,03. Ensuite la prédiction conforme : des ensembles de types qui contiennent le vrai type 90 % du temps, et c'est tenu. La règle d'escalade : si l'ensemble mélange bénin et malin, on transmet au dermatologue. Compromis : l'hybride escalade deux fois moins, 22,5 % contre 42,8 %, mais laisse passer plus de malins sans alerte, 28 % contre 20 %. Aucun des deux n'est acceptable pour un vrai dépistage. Exemple d'explication à montrer si on a le temps : un mélanome reconnu à 0,55, ensemble {mel, nv}, donc escaladé : le modèle n'exclut pas le bénin mais ne laisse pas passer le malin.</a:t>
+              <a:t>ALEXIS (1:15). Pour exploiter l'incertitude : d'abord la température, qui ramène l'ECE de 0,14 à 0,03 pour la référence. Ensuite la prédiction conforme : des ensembles de types qui contiennent le vrai type 90 % du temps, et c'est tenu. La règle d'escalade : si l'ensemble mélange bénin et malin, on transmet au dermatologue. Compromis : l'hybride escalade presque deux fois moins, 24,8 % contre 44,2 %, mais laisse passer plus de malins sans alerte, 26,5 % contre 18,1 %. Aucun des deux n'est acceptable pour un vrai dépistage. Exemple d'explication à montrer si on a le temps : un mélanome reconnu à 0,51, ensemble {mel, nv}, donc escaladé : le modèle n'exclut pas le bénin mais ne laisse pas passer le malin.</a:t>
             </a:r>
             <a:endParaRPr lang="en-US" dirty="0"/>
           </a:p>
@@ -2685,7 +2685,7 @@
           <a:p>
             <a:r>
               <a:rPr lang="en-US" dirty="0"/>
-              <a:t>ALEXIS (1:30). Le résultat principal. En framboise l'hybride, en gris la référence. Avec très peu d'étiquettes fines, l'hybride garde une AUC bénin / malin de 0,86 alors que la référence tombe à 0,78 à 2 %. C'est la décision qui compte en dépistage. Les deux courbes se rejoignent à partir de 25 %. En revanche, sur le type exact, l'hybride ne fait pas mieux : 0,369 de précision équilibrée contre 0,389 pour la référence à 10 %. Côté cohérence : sans décodage, les têtes de M se contredisent sur 5,7 % des images, 3,8 % pour H, 0 % après décodage cohérent.</a:t>
+              <a:t>ALEXIS (1:30). Le résultat principal. En framboise l'hybride, en gris la référence. Avec très peu d'étiquettes fines, l'hybride garde une AUC bénin / malin de 0,86 alors que la référence tombe à 0,78 à 2 %. C'est la décision qui compte en dépistage. Les deux courbes se rejoignent à partir de 25 %. En revanche, sur le type exact, l'hybride ne fait pas mieux : 0,368 de précision équilibrée contre 0,390 pour la référence à 10 %. Côté cohérence : sans décodage, les têtes de M se contredisent sur 5,7 % des images, 3,8 % pour H, 0 % après décodage cohérent.</a:t>
             </a:r>
             <a:endParaRPr lang="en-US" dirty="0"/>
           </a:p>
@@ -2861,7 +2861,7 @@
           <a:p>
             <a:r>
               <a:rPr lang="en-US" dirty="0"/>
-              <a:t>ALEXIS (1:15). Analyse d'erreurs par brique. 54 % des erreurs sont des erreurs de groupe, 43 % des erreurs à l'intérieur du bon groupe, que la hiérarchie ne peut pas corriger, et seulement 3 % viennent du décodage symbolique. Le goulot, c'est la perception : à 28×28, le mélanome est confondu avec le nævus dans la moitié des cas. Cas difficiles : face à des chiffres manuscrits, tous les modèles répondent malin avec 99 % de confiance ; la hiérarchie choisit parmi les 7 types connus, elle ne sait pas dire aucun. Sous sous-exposition, l'hybride garde une meilleure AUC malin.</a:t>
+              <a:t>ALEXIS (1:15). Analyse d'erreurs par brique. 56 % des erreurs sont des erreurs de groupe, 43 % des erreurs à l'intérieur du bon groupe, que la hiérarchie ne peut pas corriger, et seulement 2 % viennent du décodage symbolique, qui en corrige d'ailleurs autant qu'il en introduit. Le goulot, c'est la perception : à 28×28, le mélanome est confondu avec le nævus dans la moitié des cas. Cas difficiles : face à des chiffres manuscrits, tous les modèles répondent malin avec 99 % de confiance ; la hiérarchie choisit parmi les 7 types connus, elle ne sait pas dire aucun. Sous sous-exposition, l'hybride garde une meilleure AUC malin.</a:t>
             </a:r>
             <a:endParaRPr lang="en-US" dirty="0"/>
           </a:p>
@@ -3830,7 +3830,7 @@
                   <a:schemeClr val="tx2"/>
                 </a:solidFill>
               </a:rPr>
-              <a:t>ECE de la référence à 10 % après mise à l'échelle par température (0,11 → 0,03 pour H)</a:t>
+              <a:t>ECE de la référence à 10 % après mise à l'échelle par température (0,11 → 0,04 pour H)</a:t>
             </a:r>
             <a:endParaRPr lang="en-US" sz="1400" dirty="0"/>
           </a:p>
@@ -9347,7 +9347,7 @@
                 <a:ea typeface="Cambria" pitchFamily="34" charset="-122"/>
                 <a:cs typeface="Cambria" pitchFamily="34" charset="-120"/>
               </a:rPr>
-              <a:t>+0,083</a:t>
+              <a:t>+0,081</a:t>
             </a:r>
             <a:endParaRPr lang="en-US" sz="4800" dirty="0"/>
           </a:p>
@@ -9383,7 +9383,7 @@
                   <a:schemeClr val="tx2"/>
                 </a:solidFill>
               </a:rPr>
-              <a:t>d'AUC bénin / malin à 2 % d'étiquettes (0,859 contre 0,776)</a:t>
+              <a:t>d'AUC bénin / malin à 2 % d'étiquettes (0,857 contre 0,776)</a:t>
             </a:r>
             <a:endParaRPr lang="en-US" sz="1400" dirty="0"/>
           </a:p>
@@ -9460,7 +9460,7 @@
                   <a:schemeClr val="tx2"/>
                 </a:solidFill>
               </a:rPr>
-              <a:t>Précision équilibrée à 10 % : R 0,389, M 0,384, H 0,369. À 100 %, R est meilleur partout.</a:t>
+              <a:t>Précision équilibrée à 10 % : R 0,390, M 0,385, H 0,368. À 100 %, R est meilleur partout.</a:t>
             </a:r>
             <a:endParaRPr lang="en-US" sz="1600" dirty="0"/>
           </a:p>
@@ -9957,7 +9957,7 @@
                             <a:srgbClr val="2A1A2E"/>
                           </a:solidFill>
                         </a:rPr>
-                        <a:t>0,369</a:t>
+                        <a:t>0,368</a:t>
                       </a:r>
                       <a:endParaRPr lang="en-US" sz="1500" dirty="0"/>
                     </a:p>
@@ -10015,7 +10015,7 @@
                             <a:srgbClr val="2A1A2E"/>
                           </a:solidFill>
                         </a:rPr>
-                        <a:t>0,487</a:t>
+                        <a:t>0,485</a:t>
                       </a:r>
                       <a:endParaRPr lang="en-US" sz="1500" dirty="0"/>
                     </a:p>
@@ -10191,7 +10191,7 @@
                             <a:srgbClr val="2A1A2E"/>
                           </a:solidFill>
                         </a:rPr>
-                        <a:t>0,375</a:t>
+                        <a:t>0,377</a:t>
                       </a:r>
                       <a:endParaRPr lang="en-US" sz="1500" dirty="0"/>
                     </a:p>
@@ -10249,7 +10249,7 @@
                             <a:srgbClr val="2A1A2E"/>
                           </a:solidFill>
                         </a:rPr>
-                        <a:t>0,463</a:t>
+                        <a:t>0,470</a:t>
                       </a:r>
                       <a:endParaRPr lang="en-US" sz="1500" dirty="0"/>
                     </a:p>
@@ -10425,7 +10425,7 @@
                             <a:srgbClr val="2A1A2E"/>
                           </a:solidFill>
                         </a:rPr>
-                        <a:t>0,385</a:t>
+                        <a:t>0,383</a:t>
                       </a:r>
                       <a:endParaRPr lang="en-US" sz="1500" dirty="0"/>
                     </a:p>
@@ -10483,7 +10483,7 @@
                             <a:srgbClr val="B8235A"/>
                           </a:solidFill>
                         </a:rPr>
-                        <a:t>0,509</a:t>
+                        <a:t>0,507</a:t>
                       </a:r>
                       <a:endParaRPr lang="en-US" sz="1500" dirty="0"/>
                     </a:p>
@@ -10536,12 +10536,12 @@
                         <a:buNone/>
                       </a:pPr>
                       <a:r>
-                        <a:rPr lang="en-US" sz="1500" b="1" dirty="0">
+                        <a:rPr lang="en-US" sz="1500" dirty="0">
                           <a:solidFill>
-                            <a:srgbClr val="B8235A"/>
+                            <a:srgbClr val="2A1A2E"/>
                           </a:solidFill>
                         </a:rPr>
-                        <a:t>0,865</a:t>
+                        <a:t>0,864</a:t>
                       </a:r>
                       <a:endParaRPr lang="en-US" sz="1500" dirty="0"/>
                     </a:p>
@@ -10659,7 +10659,7 @@
                             <a:srgbClr val="2A1A2E"/>
                           </a:solidFill>
                         </a:rPr>
-                        <a:t>0,384</a:t>
+                        <a:t>0,378</a:t>
                       </a:r>
                       <a:endParaRPr lang="en-US" sz="1500" dirty="0"/>
                     </a:p>
@@ -10717,7 +10717,7 @@
                             <a:srgbClr val="2A1A2E"/>
                           </a:solidFill>
                         </a:rPr>
-                        <a:t>0,500</a:t>
+                        <a:t>0,504</a:t>
                       </a:r>
                       <a:endParaRPr lang="en-US" sz="1500" dirty="0"/>
                     </a:p>
@@ -10888,12 +10888,12 @@
                         <a:buNone/>
                       </a:pPr>
                       <a:r>
-                        <a:rPr lang="en-US" sz="1500" b="1" dirty="0">
+                        <a:rPr lang="en-US" sz="1500" dirty="0">
                           <a:solidFill>
-                            <a:srgbClr val="B8235A"/>
+                            <a:srgbClr val="2A1A2E"/>
                           </a:solidFill>
                         </a:rPr>
-                        <a:t>0,388</a:t>
+                        <a:t>0,389</a:t>
                       </a:r>
                       <a:endParaRPr lang="en-US" sz="1500" dirty="0"/>
                     </a:p>
@@ -10951,7 +10951,7 @@
                             <a:srgbClr val="2A1A2E"/>
                           </a:solidFill>
                         </a:rPr>
-                        <a:t>0,484</a:t>
+                        <a:t>0,485</a:t>
                       </a:r>
                       <a:endParaRPr lang="en-US" sz="1500" dirty="0"/>
                     </a:p>
@@ -11004,12 +11004,12 @@
                         <a:buNone/>
                       </a:pPr>
                       <a:r>
-                        <a:rPr lang="en-US" sz="1500" dirty="0">
+                        <a:rPr lang="en-US" sz="1500" b="1" dirty="0">
                           <a:solidFill>
-                            <a:srgbClr val="2A1A2E"/>
+                            <a:srgbClr val="B8235A"/>
                           </a:solidFill>
                         </a:rPr>
-                        <a:t>0,864</a:t>
+                        <a:t>0,865</a:t>
                       </a:r>
                       <a:endParaRPr lang="en-US" sz="1500" dirty="0"/>
                     </a:p>
@@ -11127,7 +11127,7 @@
                             <a:srgbClr val="B8235A"/>
                           </a:solidFill>
                         </a:rPr>
-                        <a:t>0,389</a:t>
+                        <a:t>0,390</a:t>
                       </a:r>
                       <a:endParaRPr lang="en-US" sz="1500" dirty="0"/>
                     </a:p>
@@ -11185,7 +11185,7 @@
                             <a:srgbClr val="2A1A2E"/>
                           </a:solidFill>
                         </a:rPr>
-                        <a:t>0,482</a:t>
+                        <a:t>0,486</a:t>
                       </a:r>
                       <a:endParaRPr lang="en-US" sz="1500" dirty="0"/>
                     </a:p>
@@ -11243,7 +11243,7 @@
                             <a:srgbClr val="2A1A2E"/>
                           </a:solidFill>
                         </a:rPr>
-                        <a:t>0,817</a:t>
+                        <a:t>0,818</a:t>
                       </a:r>
                       <a:endParaRPr lang="en-US" sz="1500" dirty="0"/>
                     </a:p>
@@ -11427,7 +11427,7 @@
                   <a:schemeClr val="tx1"/>
                 </a:solidFill>
               </a:rPr>
-              <a:t>Le plus simple pour la satisfaire : tout mettre sur nv. La règle renforce la classe dominante (vasc : 0,14 pour H contre 0,26 pour R).</a:t>
+              <a:t>Le plus simple pour la satisfaire : tout mettre sur nv. La règle renforce la classe dominante (vasc : 0,15 pour H contre 0,25 pour R).</a:t>
             </a:r>
             <a:endParaRPr lang="en-US" sz="1500" dirty="0"/>
           </a:p>
@@ -11563,7 +11563,7 @@
                   <a:schemeClr val="tx1"/>
                 </a:solidFill>
               </a:rPr>
-              <a:t>97 % des erreurs viennent de la perception</a:t>
+              <a:t>98 % des erreurs viennent de la perception</a:t>
             </a:r>
             <a:endParaRPr lang="en-US" sz="3000" dirty="0"/>
           </a:p>
@@ -11645,7 +11645,7 @@
                 <a:ea typeface="Cambria" pitchFamily="34" charset="-122"/>
                 <a:cs typeface="Cambria" pitchFamily="34" charset="-120"/>
               </a:rPr>
-              <a:t>117 / 223</a:t>
+              <a:t>119 / 223</a:t>
             </a:r>
             <a:endParaRPr lang="en-US" sz="2600" dirty="0"/>
           </a:p>
@@ -11849,7 +11849,7 @@
                 <a:ea typeface="Cambria" pitchFamily="34" charset="-122"/>
                 <a:cs typeface="Cambria" pitchFamily="34" charset="-120"/>
               </a:rPr>
-              <a:t>0,64 vs 0,42</a:t>
+              <a:t>0,66 vs 0,42</a:t>
             </a:r>
             <a:endParaRPr lang="en-US" sz="2600" dirty="0"/>
           </a:p>

</xml_diff>